<commit_message>
chore(ui): dark mode dinamico, insets corretos, colaboradores na bottom bar e cleanup de entregaveis
- Refatora Color.kt/Theme.kt/InnovateUi.kt para cores theme-aware (claro/escuro)
- Aplica WindowInsets.safeDrawing em InnovateScreenBackground e CollaboratorsChatScreen
- Remove Spacers redundantes ao final de Profile/Ideas (Scaffold ja cuida do bottom inset)
- Move tela de Colaboradores para dentro do Scaffold (mantem bottom bar visivel)
- Substitui Color.White hardcoded por InnovateSurface em containers
- Remove altura fixa da NavigationBar (resolve overlap com gesture pill)
- Atualiza Compose BOM para 2026.05.00 (compatibilidade ABI/runtime)
- Atualiza .pptx tecnico e zip de codigo-fonte; remove web-preview da entrega
- Reforca .gitignore (.idea/, *.apk, .kotlin, app/build)

Co-authored-by: Cursor <cursoragent@cursor.com>
</commit_message>
<xml_diff>
--- a/entregas/documentacao/documentacao-tecnica.pptx
+++ b/entregas/documentacao/documentacao-tecnica.pptx
@@ -10,6 +10,8 @@
     <p:sldId id="261" r:id="rId6"/>
     <p:sldId id="262" r:id="rId7"/>
     <p:sldId id="263" r:id="rId8"/>
+    <p:sldId id="264" r:id="rId9"/>
+    <p:sldId id="265" r:id="rId10"/>
   </p:sldIdLst>
   <p:sldSz cx="12192000" cy="6858000" type="screen16x9"/>
   <p:notesSz cx="6858000" cy="9144000"/>
@@ -61,7 +63,7 @@
             <a:r>
               <a:rPr lang="pt-BR" sz="4000" b="1">
                 <a:solidFill>
-                  <a:srgbClr val="FFFFFF"/>
+                  <a:srgbClr val="6C5CE7"/>
                 </a:solidFill>
               </a:rPr>
               <a:t>Challenge Ãguia Branca</a:t>
@@ -88,20 +90,172 @@
           <a:lstStyle/>
           <a:p>
             <a:r>
-              <a:rPr lang="pt-BR" sz="2200"/>
+              <a:rPr lang="pt-BR" sz="2000">
+                <a:solidFill>
+                  <a:srgbClr val="E2E8F0"/>
+                </a:solidFill>
+              </a:rPr>
               <a:t>GestÃ£o de InovaÃ§Ã£o Corporativa</a:t>
             </a:r>
           </a:p>
           <a:p>
             <a:r>
-              <a:rPr lang="pt-BR" sz="2200"/>
-              <a:t>Aplicativo Android nativo com preview web para demonstraÃ§Ã£o</a:t>
-            </a:r>
-          </a:p>
-          <a:p>
-            <a:r>
-              <a:rPr lang="pt-BR" sz="2200"/>
-              <a:t>Perfis: Operador, Gestor e LÃ­der</a:t>
+              <a:rPr lang="pt-BR" sz="2000">
+                <a:solidFill>
+                  <a:srgbClr val="E2E8F0"/>
+                </a:solidFill>
+              </a:rPr>
+              <a:t>Aplicativo Android nativo (Kotlin + Jetpack Compose)</a:t>
+            </a:r>
+          </a:p>
+          <a:p>
+            <a:r>
+              <a:rPr lang="pt-BR" sz="2000">
+                <a:solidFill>
+                  <a:srgbClr val="E2E8F0"/>
+                </a:solidFill>
+              </a:rPr>
+              <a:t>TrÃªs perfis com fluxos dedicados: Operador, Gestor e LÃ­der</a:t>
+            </a:r>
+          </a:p>
+          <a:p>
+            <a:r>
+              <a:rPr lang="pt-BR" sz="2000">
+                <a:solidFill>
+                  <a:srgbClr val="E2E8F0"/>
+                </a:solidFill>
+              </a:rPr>
+              <a:t>Tema dinÃ¢mico (claro/escuro) e identidade visual por perfil</a:t>
+            </a:r>
+          </a:p>
+        </p:txBody>
+      </p:sp>
+    </p:spTree>
+  </p:cSld>
+  <p:clrMapOvr>
+    <a:masterClrMapping/>
+  </p:clrMapOvr>
+</p:sld>
+</file>
+
+<file path=ppt\slides\slide10.xml><?xml version="1.0" encoding="utf-8"?>
+<p:sld xmlns:a="http://schemas.openxmlformats.org/drawingml/2006/main" xmlns:r="http://schemas.openxmlformats.org/officeDocument/2006/relationships" xmlns:p="http://schemas.openxmlformats.org/presentationml/2006/main">
+  <p:cSld>
+    <p:bg>
+      <p:bgPr>
+        <a:solidFill>
+          <a:srgbClr val="0B1220"/>
+        </a:solidFill>
+      </p:bgPr>
+    </p:bg>
+    <p:spTree>
+      <p:nvGrpSpPr>
+        <p:cNvPr id="1" name=""/>
+        <p:cNvGrpSpPr/>
+        <p:nvPr/>
+      </p:nvGrpSpPr>
+      <p:grpSpPr>
+        <a:xfrm>
+          <a:off x="0" y="0"/>
+          <a:ext cx="0" cy="0"/>
+          <a:chOff x="0" y="0"/>
+          <a:chExt cx="0" cy="0"/>
+        </a:xfrm>
+      </p:grpSpPr>
+      <p:sp>
+        <p:nvSpPr>
+          <p:cNvPr id="2" name="Title"/>
+          <p:cNvSpPr>
+            <a:spLocks noGrp="1"/>
+          </p:cNvSpPr>
+          <p:nvPr/>
+        </p:nvSpPr>
+        <p:spPr>
+          <a:xfrm>
+            <a:off x="685800" y="457200"/>
+            <a:ext cx="10820400" cy="1143000"/>
+          </a:xfrm>
+        </p:spPr>
+        <p:txBody>
+          <a:bodyPr/>
+          <a:lstStyle/>
+          <a:p>
+            <a:r>
+              <a:rPr lang="pt-BR" sz="4000" b="1">
+                <a:solidFill>
+                  <a:srgbClr val="6C5CE7"/>
+                </a:solidFill>
+              </a:rPr>
+              <a:t>EntregÃ¡veis</a:t>
+            </a:r>
+          </a:p>
+        </p:txBody>
+      </p:sp>
+      <p:sp>
+        <p:nvSpPr>
+          <p:cNvPr id="3" name="Content"/>
+          <p:cNvSpPr>
+            <a:spLocks noGrp="1"/>
+          </p:cNvSpPr>
+          <p:nvPr/>
+        </p:nvSpPr>
+        <p:spPr>
+          <a:xfrm>
+            <a:off x="914400" y="1905000"/>
+            <a:ext cx="10363200" cy="4114800"/>
+          </a:xfrm>
+        </p:spPr>
+        <p:txBody>
+          <a:bodyPr/>
+          <a:lstStyle/>
+          <a:p>
+            <a:r>
+              <a:rPr lang="pt-BR" sz="2000">
+                <a:solidFill>
+                  <a:srgbClr val="E2E8F0"/>
+                </a:solidFill>
+              </a:rPr>
+              <a:t>APK Android assinado em modo debug</a:t>
+            </a:r>
+          </a:p>
+          <a:p>
+            <a:r>
+              <a:rPr lang="pt-BR" sz="2000">
+                <a:solidFill>
+                  <a:srgbClr val="E2E8F0"/>
+                </a:solidFill>
+              </a:rPr>
+              <a:t>CÃ³digo-fonte completo compactado em .zip</a:t>
+            </a:r>
+          </a:p>
+          <a:p>
+            <a:r>
+              <a:rPr lang="pt-BR" sz="2000">
+                <a:solidFill>
+                  <a:srgbClr val="E2E8F0"/>
+                </a:solidFill>
+              </a:rPr>
+              <a:t>DocumentaÃ§Ã£o tÃ©cnica em PPTX</a:t>
+            </a:r>
+          </a:p>
+          <a:p>
+            <a:r>
+              <a:rPr lang="pt-BR" sz="2000">
+                <a:solidFill>
+                  <a:srgbClr val="E2E8F0"/>
+                </a:solidFill>
+              </a:rPr>
+              <a:t>Roteiro do vÃ­deo demonstrativo (atÃ© 5 minutos)</a:t>
+            </a:r>
+          </a:p>
+          <a:p>
+            <a:r>
+              <a:rPr lang="pt-BR" sz="2000">
+                <a:solidFill>
+                  <a:srgbClr val="E2E8F0"/>
+                </a:solidFill>
+              </a:rPr>
+              <a:t>CritÃ©rios atendidos: autenticaÃ§Ã£o, CRUD por perfil, dashboard de ROI e conectividade REST + DB local</a:t>
             </a:r>
           </a:p>
         </p:txBody>
@@ -159,7 +313,7 @@
             <a:r>
               <a:rPr lang="pt-BR" sz="4000" b="1">
                 <a:solidFill>
-                  <a:srgbClr val="FFFFFF"/>
+                  <a:srgbClr val="6C5CE7"/>
                 </a:solidFill>
               </a:rPr>
               <a:t>Tecnologias Utilizadas</a:t>
@@ -186,38 +340,82 @@
           <a:lstStyle/>
           <a:p>
             <a:r>
-              <a:rPr lang="pt-BR" sz="2200"/>
-              <a:t>Android: Kotlin, Jetpack Compose, Material 3 e Navigation Compose</a:t>
-            </a:r>
-          </a:p>
-          <a:p>
-            <a:r>
-              <a:rPr lang="pt-BR" sz="2200"/>
-              <a:t>Arquitetura: MVVM + Clean Architecture</a:t>
-            </a:r>
-          </a:p>
-          <a:p>
-            <a:r>
-              <a:rPr lang="pt-BR" sz="2200"/>
+              <a:rPr lang="pt-BR" sz="2000">
+                <a:solidFill>
+                  <a:srgbClr val="E2E8F0"/>
+                </a:solidFill>
+              </a:rPr>
+              <a:t>Linguagem: Kotlin 2.x</a:t>
+            </a:r>
+          </a:p>
+          <a:p>
+            <a:r>
+              <a:rPr lang="pt-BR" sz="2000">
+                <a:solidFill>
+                  <a:srgbClr val="E2E8F0"/>
+                </a:solidFill>
+              </a:rPr>
+              <a:t>UI: Jetpack Compose + Material 3 (BOM 2026.05.00)</a:t>
+            </a:r>
+          </a:p>
+          <a:p>
+            <a:r>
+              <a:rPr lang="pt-BR" sz="2000">
+                <a:solidFill>
+                  <a:srgbClr val="E2E8F0"/>
+                </a:solidFill>
+              </a:rPr>
+              <a:t>Arquitetura: MVVM + Clean Architecture (data / domain / ui)</a:t>
+            </a:r>
+          </a:p>
+          <a:p>
+            <a:r>
+              <a:rPr lang="pt-BR" sz="2000">
+                <a:solidFill>
+                  <a:srgbClr val="E2E8F0"/>
+                </a:solidFill>
+              </a:rPr>
               <a:t>InjeÃ§Ã£o de dependÃªncia: Koin</a:t>
             </a:r>
           </a:p>
           <a:p>
             <a:r>
-              <a:rPr lang="pt-BR" sz="2200"/>
-              <a:t>PersistÃªncia local: Room e DataStore</a:t>
-            </a:r>
-          </a:p>
-          <a:p>
-            <a:r>
-              <a:rPr lang="pt-BR" sz="2200"/>
-              <a:t>Rede: Retrofit, OkHttp e Kotlinx Serialization</a:t>
-            </a:r>
-          </a:p>
-          <a:p>
-            <a:r>
-              <a:rPr lang="pt-BR" sz="2200"/>
-              <a:t>Web preview: Vite, JavaScript, HTML e CSS</a:t>
+              <a:rPr lang="pt-BR" sz="2000">
+                <a:solidFill>
+                  <a:srgbClr val="E2E8F0"/>
+                </a:solidFill>
+              </a:rPr>
+              <a:t>PersistÃªncia local: Room + DataStore</a:t>
+            </a:r>
+          </a:p>
+          <a:p>
+            <a:r>
+              <a:rPr lang="pt-BR" sz="2000">
+                <a:solidFill>
+                  <a:srgbClr val="E2E8F0"/>
+                </a:solidFill>
+              </a:rPr>
+              <a:t>Rede: Retrofit + OkHttp + Kotlinx Serialization</a:t>
+            </a:r>
+          </a:p>
+          <a:p>
+            <a:r>
+              <a:rPr lang="pt-BR" sz="2000">
+                <a:solidFill>
+                  <a:srgbClr val="E2E8F0"/>
+                </a:solidFill>
+              </a:rPr>
+              <a:t>ConcorrÃªncia: Coroutines + Flow</a:t>
+            </a:r>
+          </a:p>
+          <a:p>
+            <a:r>
+              <a:rPr lang="pt-BR" sz="2000">
+                <a:solidFill>
+                  <a:srgbClr val="E2E8F0"/>
+                </a:solidFill>
+              </a:rPr>
+              <a:t>Gradle Kotlin DSL com Version Catalog (libs.versions.toml)</a:t>
             </a:r>
           </a:p>
         </p:txBody>
@@ -275,7 +473,7 @@
             <a:r>
               <a:rPr lang="pt-BR" sz="4000" b="1">
                 <a:solidFill>
-                  <a:srgbClr val="FFFFFF"/>
+                  <a:srgbClr val="6C5CE7"/>
                 </a:solidFill>
               </a:rPr>
               <a:t>Arquitetura da SoluÃ§Ã£o</a:t>
@@ -302,26 +500,62 @@
           <a:lstStyle/>
           <a:p>
             <a:r>
-              <a:rPr lang="pt-BR" sz="2200"/>
-              <a:t>Camada Data: APIs remotas, banco local Room, DAOs, DTOs e repositÃ³rios</a:t>
-            </a:r>
-          </a:p>
-          <a:p>
-            <a:r>
-              <a:rPr lang="pt-BR" sz="2200"/>
-              <a:t>Camada Domain: modelos, contratos de repositÃ³rio e casos de uso</a:t>
-            </a:r>
-          </a:p>
-          <a:p>
-            <a:r>
-              <a:rPr lang="pt-BR" sz="2200"/>
-              <a:t>Camada UI: telas Compose, ViewModels, estados de tela e componentes reutilizÃ¡veis</a:t>
-            </a:r>
-          </a:p>
-          <a:p>
-            <a:r>
-              <a:rPr lang="pt-BR" sz="2200"/>
-              <a:t>SeparaÃ§Ã£o por feature: auth, operator, manager e leader</a:t>
+              <a:rPr lang="pt-BR" sz="2000">
+                <a:solidFill>
+                  <a:srgbClr val="E2E8F0"/>
+                </a:solidFill>
+              </a:rPr>
+              <a:t>Camada Data: APIs remotas (Retrofit), banco local Room, DAOs, DTOs, mappers e repositÃ³rios</a:t>
+            </a:r>
+          </a:p>
+          <a:p>
+            <a:r>
+              <a:rPr lang="pt-BR" sz="2000">
+                <a:solidFill>
+                  <a:srgbClr val="E2E8F0"/>
+                </a:solidFill>
+              </a:rPr>
+              <a:t>Camada Domain: modelos puros, contratos de repositÃ³rio e Use Cases por feature</a:t>
+            </a:r>
+          </a:p>
+          <a:p>
+            <a:r>
+              <a:rPr lang="pt-BR" sz="2000">
+                <a:solidFill>
+                  <a:srgbClr val="E2E8F0"/>
+                </a:solidFill>
+              </a:rPr>
+              <a:t>Camada UI: telas Compose, ViewModels com StateFlow e componentes reutilizÃ¡veis</a:t>
+            </a:r>
+          </a:p>
+          <a:p>
+            <a:r>
+              <a:rPr lang="pt-BR" sz="2000">
+                <a:solidFill>
+                  <a:srgbClr val="E2E8F0"/>
+                </a:solidFill>
+              </a:rPr>
+              <a:t>OrganizaÃ§Ã£o por feature: auth, operator, manager, leader e shared</a:t>
+            </a:r>
+          </a:p>
+          <a:p>
+            <a:r>
+              <a:rPr lang="pt-BR" sz="2000">
+                <a:solidFill>
+                  <a:srgbClr val="E2E8F0"/>
+                </a:solidFill>
+              </a:rPr>
+              <a:t>NavegaÃ§Ã£o centralizada com Compose Navigation</a:t>
+            </a:r>
+          </a:p>
+          <a:p>
+            <a:r>
+              <a:rPr lang="pt-BR" sz="2000">
+                <a:solidFill>
+                  <a:srgbClr val="E2E8F0"/>
+                </a:solidFill>
+              </a:rPr>
+              <a:t>RoleThemedScreen aplica esquema de cores por perfil em runtime</a:t>
             </a:r>
           </a:p>
         </p:txBody>
@@ -379,10 +613,10 @@
             <a:r>
               <a:rPr lang="pt-BR" sz="4000" b="1">
                 <a:solidFill>
-                  <a:srgbClr val="FFFFFF"/>
-                </a:solidFill>
-              </a:rPr>
-              <a:t>Fluxo da AplicaÃ§Ã£o</a:t>
+                  <a:srgbClr val="6C5CE7"/>
+                </a:solidFill>
+              </a:rPr>
+              <a:t>Conectividade com ServiÃ§os Externos</a:t>
             </a:r>
           </a:p>
         </p:txBody>
@@ -406,32 +640,52 @@
           <a:lstStyle/>
           <a:p>
             <a:r>
-              <a:rPr lang="pt-BR" sz="2200"/>
-              <a:t>1. UsuÃ¡rio acessa a tela de login</a:t>
-            </a:r>
-          </a:p>
-          <a:p>
-            <a:r>
-              <a:rPr lang="pt-BR" sz="2200"/>
-              <a:t>2. Credenciais mockadas definem automaticamente o perfil</a:t>
-            </a:r>
-          </a:p>
-          <a:p>
-            <a:r>
-              <a:rPr lang="pt-BR" sz="2200"/>
-              <a:t>3. A sessÃ£o Ã© salva localmente</a:t>
-            </a:r>
-          </a:p>
-          <a:p>
-            <a:r>
-              <a:rPr lang="pt-BR" sz="2200"/>
-              <a:t>4. A navegaÃ§Ã£o direciona para a home correta do perfil</a:t>
-            </a:r>
-          </a:p>
-          <a:p>
-            <a:r>
-              <a:rPr lang="pt-BR" sz="2200"/>
-              <a:t>5. Cada perfil acessa funcionalidades especÃ­ficas por regra de negÃ³cio</a:t>
+              <a:rPr lang="pt-BR" sz="2000">
+                <a:solidFill>
+                  <a:srgbClr val="E2E8F0"/>
+                </a:solidFill>
+              </a:rPr>
+              <a:t>REST API real - FakerAPI (https://fakerapi.it/api/v1/users) para seed inicial de usuÃ¡rios</a:t>
+            </a:r>
+          </a:p>
+          <a:p>
+            <a:r>
+              <a:rPr lang="pt-BR" sz="2000">
+                <a:solidFill>
+                  <a:srgbClr val="E2E8F0"/>
+                </a:solidFill>
+              </a:rPr>
+              <a:t>REST API real - AdviceSlip (https://api.adviceslip.com/advice) para o Insight do Dia</a:t>
+            </a:r>
+          </a:p>
+          <a:p>
+            <a:r>
+              <a:rPr lang="pt-BR" sz="2000">
+                <a:solidFill>
+                  <a:srgbClr val="E2E8F0"/>
+                </a:solidFill>
+              </a:rPr>
+              <a:t>Banco de dados local em Room com 4 entidades: Idea, Project, StrategicGuideline e Session</a:t>
+            </a:r>
+          </a:p>
+          <a:p>
+            <a:r>
+              <a:rPr lang="pt-BR" sz="2000">
+                <a:solidFill>
+                  <a:srgbClr val="E2E8F0"/>
+                </a:solidFill>
+              </a:rPr>
+              <a:t>DAO + Flow para reatividade ponta a ponta entre banco e UI</a:t>
+            </a:r>
+          </a:p>
+          <a:p>
+            <a:r>
+              <a:rPr lang="pt-BR" sz="2000">
+                <a:solidFill>
+                  <a:srgbClr val="E2E8F0"/>
+                </a:solidFill>
+              </a:rPr>
+              <a:t>Tratamento robusto de erros e estados de loading/empty/error em cada chamada</a:t>
             </a:r>
           </a:p>
         </p:txBody>
@@ -489,10 +743,10 @@
             <a:r>
               <a:rPr lang="pt-BR" sz="4000" b="1">
                 <a:solidFill>
-                  <a:srgbClr val="FFFFFF"/>
-                </a:solidFill>
-              </a:rPr>
-              <a:t>Funcionalidades do Operador</a:t>
+                  <a:srgbClr val="6C5CE7"/>
+                </a:solidFill>
+              </a:rPr>
+              <a:t>Fluxo da AplicaÃ§Ã£o</a:t>
             </a:r>
           </a:p>
         </p:txBody>
@@ -516,26 +770,52 @@
           <a:lstStyle/>
           <a:p>
             <a:r>
-              <a:rPr lang="pt-BR" sz="2200"/>
-              <a:t>Home com KPIs, insight do dia e diretrizes estratÃ©gicas</a:t>
-            </a:r>
-          </a:p>
-          <a:p>
-            <a:r>
-              <a:rPr lang="pt-BR" sz="2200"/>
-              <a:t>Cadastro de novas ideias e reporte de problemas</a:t>
-            </a:r>
-          </a:p>
-          <a:p>
-            <a:r>
-              <a:rPr lang="pt-BR" sz="2200"/>
-              <a:t>Listagem das prÃ³prias ideias com status</a:t>
-            </a:r>
-          </a:p>
-          <a:p>
-            <a:r>
-              <a:rPr lang="pt-BR" sz="2200"/>
-              <a:t>Perfil com gamificaÃ§Ã£o, pontos e resumo de participaÃ§Ã£o</a:t>
+              <a:rPr lang="pt-BR" sz="2000">
+                <a:solidFill>
+                  <a:srgbClr val="E2E8F0"/>
+                </a:solidFill>
+              </a:rPr>
+              <a:t>1. Tela de login com seleÃ§Ã£o e validaÃ§Ã£o de credenciais por perfil</a:t>
+            </a:r>
+          </a:p>
+          <a:p>
+            <a:r>
+              <a:rPr lang="pt-BR" sz="2000">
+                <a:solidFill>
+                  <a:srgbClr val="E2E8F0"/>
+                </a:solidFill>
+              </a:rPr>
+              <a:t>2. SessÃ£o persistida localmente via Room (SessionRepository)</a:t>
+            </a:r>
+          </a:p>
+          <a:p>
+            <a:r>
+              <a:rPr lang="pt-BR" sz="2000">
+                <a:solidFill>
+                  <a:srgbClr val="E2E8F0"/>
+                </a:solidFill>
+              </a:rPr>
+              <a:t>3. NavegaÃ§Ã£o direciona automaticamente para a home do perfil logado</a:t>
+            </a:r>
+          </a:p>
+          <a:p>
+            <a:r>
+              <a:rPr lang="pt-BR" sz="2000">
+                <a:solidFill>
+                  <a:srgbClr val="E2E8F0"/>
+                </a:solidFill>
+              </a:rPr>
+              <a:t>4. Cada perfil enxerga abas e aÃ§Ãµes conforme as regras de negÃ³cio</a:t>
+            </a:r>
+          </a:p>
+          <a:p>
+            <a:r>
+              <a:rPr lang="pt-BR" sz="2000">
+                <a:solidFill>
+                  <a:srgbClr val="E2E8F0"/>
+                </a:solidFill>
+              </a:rPr>
+              <a:t>5. Logout limpa a sessÃ£o e retorna para o login</a:t>
             </a:r>
           </a:p>
         </p:txBody>
@@ -593,10 +873,10 @@
             <a:r>
               <a:rPr lang="pt-BR" sz="4000" b="1">
                 <a:solidFill>
-                  <a:srgbClr val="FFFFFF"/>
-                </a:solidFill>
-              </a:rPr>
-              <a:t>Funcionalidades do Gestor</a:t>
+                  <a:srgbClr val="6C5CE7"/>
+                </a:solidFill>
+              </a:rPr>
+              <a:t>Funcionalidades do Operador</a:t>
             </a:r>
           </a:p>
         </p:txBody>
@@ -620,32 +900,62 @@
           <a:lstStyle/>
           <a:p>
             <a:r>
-              <a:rPr lang="pt-BR" sz="2200"/>
-              <a:t>Dashboard tÃ¡tico com indicadores e grÃ¡fico de ideias</a:t>
-            </a:r>
-          </a:p>
-          <a:p>
-            <a:r>
-              <a:rPr lang="pt-BR" sz="2200"/>
-              <a:t>Curadoria de ideias: aprovar, reprovar e priorizar</a:t>
-            </a:r>
-          </a:p>
-          <a:p>
-            <a:r>
-              <a:rPr lang="pt-BR" sz="2200"/>
-              <a:t>CRUD de projetos a partir de ideias aprovadas</a:t>
-            </a:r>
-          </a:p>
-          <a:p>
-            <a:r>
-              <a:rPr lang="pt-BR" sz="2200"/>
-              <a:t>Consulta das diretrizes da lideranÃ§a</a:t>
-            </a:r>
-          </a:p>
-          <a:p>
-            <a:r>
-              <a:rPr lang="pt-BR" sz="2200"/>
-              <a:t>Perfil e visÃ£o de equipe</a:t>
+              <a:rPr lang="pt-BR" sz="2000">
+                <a:solidFill>
+                  <a:srgbClr val="E2E8F0"/>
+                </a:solidFill>
+              </a:rPr>
+              <a:t>Home com KPIs pessoais, banner de gamificaÃ§Ã£o e aÃ§Ãµes rÃ¡pidas</a:t>
+            </a:r>
+          </a:p>
+          <a:p>
+            <a:r>
+              <a:rPr lang="pt-BR" sz="2000">
+                <a:solidFill>
+                  <a:srgbClr val="E2E8F0"/>
+                </a:solidFill>
+              </a:rPr>
+              <a:t>Insight do Dia carregado via API REST externa</a:t>
+            </a:r>
+          </a:p>
+          <a:p>
+            <a:r>
+              <a:rPr lang="pt-BR" sz="2000">
+                <a:solidFill>
+                  <a:srgbClr val="E2E8F0"/>
+                </a:solidFill>
+              </a:rPr>
+              <a:t>Cadastro e listagem de ideias com categoria e status</a:t>
+            </a:r>
+          </a:p>
+          <a:p>
+            <a:r>
+              <a:rPr lang="pt-BR" sz="2000">
+                <a:solidFill>
+                  <a:srgbClr val="E2E8F0"/>
+                </a:solidFill>
+              </a:rPr>
+              <a:t>Acesso Ã  equipe via Chat de Colaboradores (filtra por relaÃ§Ã£o direta)</a:t>
+            </a:r>
+          </a:p>
+          <a:p>
+            <a:r>
+              <a:rPr lang="pt-BR" sz="2000">
+                <a:solidFill>
+                  <a:srgbClr val="E2E8F0"/>
+                </a:solidFill>
+              </a:rPr>
+              <a:t>Consulta Ã s diretrizes estratÃ©gicas (read-only)</a:t>
+            </a:r>
+          </a:p>
+          <a:p>
+            <a:r>
+              <a:rPr lang="pt-BR" sz="2000">
+                <a:solidFill>
+                  <a:srgbClr val="E2E8F0"/>
+                </a:solidFill>
+              </a:rPr>
+              <a:t>Perfil com avatar customizÃ¡vel, pontos e nÃ­vel de gamificaÃ§Ã£o</a:t>
             </a:r>
           </a:p>
         </p:txBody>
@@ -703,10 +1013,10 @@
             <a:r>
               <a:rPr lang="pt-BR" sz="4000" b="1">
                 <a:solidFill>
-                  <a:srgbClr val="FFFFFF"/>
-                </a:solidFill>
-              </a:rPr>
-              <a:t>Funcionalidades do LÃ­der</a:t>
+                  <a:srgbClr val="6C5CE7"/>
+                </a:solidFill>
+              </a:rPr>
+              <a:t>Funcionalidades do Gestor</a:t>
             </a:r>
           </a:p>
         </p:txBody>
@@ -730,26 +1040,72 @@
           <a:lstStyle/>
           <a:p>
             <a:r>
-              <a:rPr lang="pt-BR" sz="2200"/>
-              <a:t>Dashboard executivo de ROI, investimento, lucro e produtividade</a:t>
-            </a:r>
-          </a:p>
-          <a:p>
-            <a:r>
-              <a:rPr lang="pt-BR" sz="2200"/>
-              <a:t>CRUD de diretrizes estratÃ©gicas</a:t>
-            </a:r>
-          </a:p>
-          <a:p>
-            <a:r>
-              <a:rPr lang="pt-BR" sz="2200"/>
-              <a:t>Acompanhamento dos projetos com prazo, status e retorno</a:t>
-            </a:r>
-          </a:p>
-          <a:p>
-            <a:r>
-              <a:rPr lang="pt-BR" sz="2200"/>
-              <a:t>NotificaÃ§Ãµes e visÃ£o estratÃ©gica consolidada</a:t>
+              <a:rPr lang="pt-BR" sz="2000">
+                <a:solidFill>
+                  <a:srgbClr val="E2E8F0"/>
+                </a:solidFill>
+              </a:rPr>
+              <a:t>Dashboard tÃ¡tico com indicadores agregados e grÃ¡fico de ideias</a:t>
+            </a:r>
+          </a:p>
+          <a:p>
+            <a:r>
+              <a:rPr lang="pt-BR" sz="2000">
+                <a:solidFill>
+                  <a:srgbClr val="E2E8F0"/>
+                </a:solidFill>
+              </a:rPr>
+              <a:t>Curadoria de ideias: aprovar, reprovar e priorizar</a:t>
+            </a:r>
+          </a:p>
+          <a:p>
+            <a:r>
+              <a:rPr lang="pt-BR" sz="2000">
+                <a:solidFill>
+                  <a:srgbClr val="E2E8F0"/>
+                </a:solidFill>
+              </a:rPr>
+              <a:t>CRUD completo de projetos a partir das ideias aprovadas</a:t>
+            </a:r>
+          </a:p>
+          <a:p>
+            <a:r>
+              <a:rPr lang="pt-BR" sz="2000">
+                <a:solidFill>
+                  <a:srgbClr val="E2E8F0"/>
+                </a:solidFill>
+              </a:rPr>
+              <a:t>AtualizaÃ§Ã£o de progresso, status, prazo e retorno financeiro</a:t>
+            </a:r>
+          </a:p>
+          <a:p>
+            <a:r>
+              <a:rPr lang="pt-BR" sz="2000">
+                <a:solidFill>
+                  <a:srgbClr val="E2E8F0"/>
+                </a:solidFill>
+              </a:rPr>
+              <a:t>Envio de sugestÃµes para a lideranÃ§a</a:t>
+            </a:r>
+          </a:p>
+          <a:p>
+            <a:r>
+              <a:rPr lang="pt-BR" sz="2000">
+                <a:solidFill>
+                  <a:srgbClr val="E2E8F0"/>
+                </a:solidFill>
+              </a:rPr>
+              <a:t>Chat com colaboradores diretos e visÃ£o de equipe</a:t>
+            </a:r>
+          </a:p>
+          <a:p>
+            <a:r>
+              <a:rPr lang="pt-BR" sz="2000">
+                <a:solidFill>
+                  <a:srgbClr val="E2E8F0"/>
+                </a:solidFill>
+              </a:rPr>
+              <a:t>Consulta Ã s diretrizes estratÃ©gicas</a:t>
             </a:r>
           </a:p>
         </p:txBody>
@@ -807,10 +1163,10 @@
             <a:r>
               <a:rPr lang="pt-BR" sz="4000" b="1">
                 <a:solidFill>
-                  <a:srgbClr val="FFFFFF"/>
-                </a:solidFill>
-              </a:rPr>
-              <a:t>EntregÃ¡veis</a:t>
+                  <a:srgbClr val="6C5CE7"/>
+                </a:solidFill>
+              </a:rPr>
+              <a:t>Funcionalidades do LÃ­der</a:t>
             </a:r>
           </a:p>
         </p:txBody>
@@ -834,32 +1190,212 @@
           <a:lstStyle/>
           <a:p>
             <a:r>
-              <a:rPr lang="pt-BR" sz="2200"/>
-              <a:t>Pasta web: build estÃ¡tico do preview no navegador</a:t>
-            </a:r>
-          </a:p>
-          <a:p>
-            <a:r>
-              <a:rPr lang="pt-BR" sz="2200"/>
-              <a:t>Pasta apk: local destinado ao APK Android</a:t>
-            </a:r>
-          </a:p>
-          <a:p>
-            <a:r>
-              <a:rPr lang="pt-BR" sz="2200"/>
-              <a:t>CÃ³digo-fonte completo compactado em .zip</a:t>
-            </a:r>
-          </a:p>
-          <a:p>
-            <a:r>
-              <a:rPr lang="pt-BR" sz="2200"/>
-              <a:t>DocumentaÃ§Ã£o tÃ©cnica em PPTX</a:t>
-            </a:r>
-          </a:p>
-          <a:p>
-            <a:r>
-              <a:rPr lang="pt-BR" sz="2200"/>
-              <a:t>Material de apoio para vÃ­deo demonstrativo de atÃ© 5 minutos</a:t>
+              <a:rPr lang="pt-BR" sz="2000">
+                <a:solidFill>
+                  <a:srgbClr val="E2E8F0"/>
+                </a:solidFill>
+              </a:rPr>
+              <a:t>Dashboard executivo: ROI, investimento, lucro, prazo e produtividade</a:t>
+            </a:r>
+          </a:p>
+          <a:p>
+            <a:r>
+              <a:rPr lang="pt-BR" sz="2000">
+                <a:solidFill>
+                  <a:srgbClr val="E2E8F0"/>
+                </a:solidFill>
+              </a:rPr>
+              <a:t>CRUD completo de diretrizes estratÃ©gicas</a:t>
+            </a:r>
+          </a:p>
+          <a:p>
+            <a:r>
+              <a:rPr lang="pt-BR" sz="2000">
+                <a:solidFill>
+                  <a:srgbClr val="E2E8F0"/>
+                </a:solidFill>
+              </a:rPr>
+              <a:t>Acompanhamento de projetos com etapa, status, investimento e retorno</a:t>
+            </a:r>
+          </a:p>
+          <a:p>
+            <a:r>
+              <a:rPr lang="pt-BR" sz="2000">
+                <a:solidFill>
+                  <a:srgbClr val="E2E8F0"/>
+                </a:solidFill>
+              </a:rPr>
+              <a:t>Ranking mensal e geral da equipe</a:t>
+            </a:r>
+          </a:p>
+          <a:p>
+            <a:r>
+              <a:rPr lang="pt-BR" sz="2000">
+                <a:solidFill>
+                  <a:srgbClr val="E2E8F0"/>
+                </a:solidFill>
+              </a:rPr>
+              <a:t>Recebimento de sugestÃµes dos gestores</a:t>
+            </a:r>
+          </a:p>
+          <a:p>
+            <a:r>
+              <a:rPr lang="pt-BR" sz="2000">
+                <a:solidFill>
+                  <a:srgbClr val="E2E8F0"/>
+                </a:solidFill>
+              </a:rPr>
+              <a:t>Chat com gestores e visÃ£o estratÃ©gica consolidada</a:t>
+            </a:r>
+          </a:p>
+        </p:txBody>
+      </p:sp>
+    </p:spTree>
+  </p:cSld>
+  <p:clrMapOvr>
+    <a:masterClrMapping/>
+  </p:clrMapOvr>
+</p:sld>
+</file>
+
+<file path=ppt\slides\slide9.xml><?xml version="1.0" encoding="utf-8"?>
+<p:sld xmlns:a="http://schemas.openxmlformats.org/drawingml/2006/main" xmlns:r="http://schemas.openxmlformats.org/officeDocument/2006/relationships" xmlns:p="http://schemas.openxmlformats.org/presentationml/2006/main">
+  <p:cSld>
+    <p:bg>
+      <p:bgPr>
+        <a:solidFill>
+          <a:srgbClr val="0B1220"/>
+        </a:solidFill>
+      </p:bgPr>
+    </p:bg>
+    <p:spTree>
+      <p:nvGrpSpPr>
+        <p:cNvPr id="1" name=""/>
+        <p:cNvGrpSpPr/>
+        <p:nvPr/>
+      </p:nvGrpSpPr>
+      <p:grpSpPr>
+        <a:xfrm>
+          <a:off x="0" y="0"/>
+          <a:ext cx="0" cy="0"/>
+          <a:chOff x="0" y="0"/>
+          <a:chExt cx="0" cy="0"/>
+        </a:xfrm>
+      </p:grpSpPr>
+      <p:sp>
+        <p:nvSpPr>
+          <p:cNvPr id="2" name="Title"/>
+          <p:cNvSpPr>
+            <a:spLocks noGrp="1"/>
+          </p:cNvSpPr>
+          <p:nvPr/>
+        </p:nvSpPr>
+        <p:spPr>
+          <a:xfrm>
+            <a:off x="685800" y="457200"/>
+            <a:ext cx="10820400" cy="1143000"/>
+          </a:xfrm>
+        </p:spPr>
+        <p:txBody>
+          <a:bodyPr/>
+          <a:lstStyle/>
+          <a:p>
+            <a:r>
+              <a:rPr lang="pt-BR" sz="4000" b="1">
+                <a:solidFill>
+                  <a:srgbClr val="6C5CE7"/>
+                </a:solidFill>
+              </a:rPr>
+              <a:t>UX e Diferenciais</a:t>
+            </a:r>
+          </a:p>
+        </p:txBody>
+      </p:sp>
+      <p:sp>
+        <p:nvSpPr>
+          <p:cNvPr id="3" name="Content"/>
+          <p:cNvSpPr>
+            <a:spLocks noGrp="1"/>
+          </p:cNvSpPr>
+          <p:nvPr/>
+        </p:nvSpPr>
+        <p:spPr>
+          <a:xfrm>
+            <a:off x="914400" y="1905000"/>
+            <a:ext cx="10363200" cy="4114800"/>
+          </a:xfrm>
+        </p:spPr>
+        <p:txBody>
+          <a:bodyPr/>
+          <a:lstStyle/>
+          <a:p>
+            <a:r>
+              <a:rPr lang="pt-BR" sz="2000">
+                <a:solidFill>
+                  <a:srgbClr val="E2E8F0"/>
+                </a:solidFill>
+              </a:rPr>
+              <a:t>Tema dinÃ¢mico claro/escuro com alternÃ¢ncia em tempo real</a:t>
+            </a:r>
+          </a:p>
+          <a:p>
+            <a:r>
+              <a:rPr lang="pt-BR" sz="2000">
+                <a:solidFill>
+                  <a:srgbClr val="E2E8F0"/>
+                </a:solidFill>
+              </a:rPr>
+              <a:t>Paleta e header coloridos por perfil (operador, gestor, lÃ­der)</a:t>
+            </a:r>
+          </a:p>
+          <a:p>
+            <a:r>
+              <a:rPr lang="pt-BR" sz="2000">
+                <a:solidFill>
+                  <a:srgbClr val="E2E8F0"/>
+                </a:solidFill>
+              </a:rPr>
+              <a:t>AnimaÃ§Ãµes premium de transiÃ§Ã£o entre abas e entrada de lista</a:t>
+            </a:r>
+          </a:p>
+          <a:p>
+            <a:r>
+              <a:rPr lang="pt-BR" sz="2000">
+                <a:solidFill>
+                  <a:srgbClr val="E2E8F0"/>
+                </a:solidFill>
+              </a:rPr>
+              <a:t>Tratamento correto de insets do sistema (status bar e barra de gestos)</a:t>
+            </a:r>
+          </a:p>
+          <a:p>
+            <a:r>
+              <a:rPr lang="pt-BR" sz="2000">
+                <a:solidFill>
+                  <a:srgbClr val="E2E8F0"/>
+                </a:solidFill>
+              </a:rPr>
+              <a:t>GamificaÃ§Ã£o: pontos, nÃ­veis e progresso de participaÃ§Ã£o</a:t>
+            </a:r>
+          </a:p>
+          <a:p>
+            <a:r>
+              <a:rPr lang="pt-BR" sz="2000">
+                <a:solidFill>
+                  <a:srgbClr val="E2E8F0"/>
+                </a:solidFill>
+              </a:rPr>
+              <a:t>NotificaÃ§Ãµes in-app por perfil com badge de nÃ£o lidos</a:t>
+            </a:r>
+          </a:p>
+          <a:p>
+            <a:r>
+              <a:rPr lang="pt-BR" sz="2000">
+                <a:solidFill>
+                  <a:srgbClr val="E2E8F0"/>
+                </a:solidFill>
+              </a:rPr>
+              <a:t>Componentes reutilizÃ¡veis (InnovateCard, InnovateScreenBackground, etc.)</a:t>
             </a:r>
           </a:p>
         </p:txBody>

</xml_diff>